<commit_message>
20/04/2026: Collections of images for the oral presentation slides and for the literature review
</commit_message>
<xml_diff>
--- a/Portfolio/presentation_skeleton/Oral_Presentation_Skeleton.pptx
+++ b/Portfolio/presentation_skeleton/Oral_Presentation_Skeleton.pptx
@@ -269,7 +269,7 @@
           <a:p>
             <a:fld id="{01A28B2F-B325-45E9-9465-5B309D137143}" type="datetimeFigureOut">
               <a:rPr lang="en-AU" smtClean="0"/>
-              <a:t>31/03/2026</a:t>
+              <a:t>19/04/2026</a:t>
             </a:fld>
             <a:endParaRPr lang="en-AU"/>
           </a:p>
@@ -469,7 +469,7 @@
           <a:p>
             <a:fld id="{01A28B2F-B325-45E9-9465-5B309D137143}" type="datetimeFigureOut">
               <a:rPr lang="en-AU" smtClean="0"/>
-              <a:t>31/03/2026</a:t>
+              <a:t>19/04/2026</a:t>
             </a:fld>
             <a:endParaRPr lang="en-AU"/>
           </a:p>
@@ -679,7 +679,7 @@
           <a:p>
             <a:fld id="{01A28B2F-B325-45E9-9465-5B309D137143}" type="datetimeFigureOut">
               <a:rPr lang="en-AU" smtClean="0"/>
-              <a:t>31/03/2026</a:t>
+              <a:t>19/04/2026</a:t>
             </a:fld>
             <a:endParaRPr lang="en-AU"/>
           </a:p>
@@ -879,7 +879,7 @@
           <a:p>
             <a:fld id="{01A28B2F-B325-45E9-9465-5B309D137143}" type="datetimeFigureOut">
               <a:rPr lang="en-AU" smtClean="0"/>
-              <a:t>31/03/2026</a:t>
+              <a:t>19/04/2026</a:t>
             </a:fld>
             <a:endParaRPr lang="en-AU"/>
           </a:p>
@@ -1155,7 +1155,7 @@
           <a:p>
             <a:fld id="{01A28B2F-B325-45E9-9465-5B309D137143}" type="datetimeFigureOut">
               <a:rPr lang="en-AU" smtClean="0"/>
-              <a:t>31/03/2026</a:t>
+              <a:t>19/04/2026</a:t>
             </a:fld>
             <a:endParaRPr lang="en-AU"/>
           </a:p>
@@ -1423,7 +1423,7 @@
           <a:p>
             <a:fld id="{01A28B2F-B325-45E9-9465-5B309D137143}" type="datetimeFigureOut">
               <a:rPr lang="en-AU" smtClean="0"/>
-              <a:t>31/03/2026</a:t>
+              <a:t>19/04/2026</a:t>
             </a:fld>
             <a:endParaRPr lang="en-AU"/>
           </a:p>
@@ -1838,7 +1838,7 @@
           <a:p>
             <a:fld id="{01A28B2F-B325-45E9-9465-5B309D137143}" type="datetimeFigureOut">
               <a:rPr lang="en-AU" smtClean="0"/>
-              <a:t>31/03/2026</a:t>
+              <a:t>19/04/2026</a:t>
             </a:fld>
             <a:endParaRPr lang="en-AU"/>
           </a:p>
@@ -1980,7 +1980,7 @@
           <a:p>
             <a:fld id="{01A28B2F-B325-45E9-9465-5B309D137143}" type="datetimeFigureOut">
               <a:rPr lang="en-AU" smtClean="0"/>
-              <a:t>31/03/2026</a:t>
+              <a:t>19/04/2026</a:t>
             </a:fld>
             <a:endParaRPr lang="en-AU"/>
           </a:p>
@@ -2093,7 +2093,7 @@
           <a:p>
             <a:fld id="{01A28B2F-B325-45E9-9465-5B309D137143}" type="datetimeFigureOut">
               <a:rPr lang="en-AU" smtClean="0"/>
-              <a:t>31/03/2026</a:t>
+              <a:t>19/04/2026</a:t>
             </a:fld>
             <a:endParaRPr lang="en-AU"/>
           </a:p>
@@ -2406,7 +2406,7 @@
           <a:p>
             <a:fld id="{01A28B2F-B325-45E9-9465-5B309D137143}" type="datetimeFigureOut">
               <a:rPr lang="en-AU" smtClean="0"/>
-              <a:t>31/03/2026</a:t>
+              <a:t>19/04/2026</a:t>
             </a:fld>
             <a:endParaRPr lang="en-AU"/>
           </a:p>
@@ -2695,7 +2695,7 @@
           <a:p>
             <a:fld id="{01A28B2F-B325-45E9-9465-5B309D137143}" type="datetimeFigureOut">
               <a:rPr lang="en-AU" smtClean="0"/>
-              <a:t>31/03/2026</a:t>
+              <a:t>19/04/2026</a:t>
             </a:fld>
             <a:endParaRPr lang="en-AU"/>
           </a:p>
@@ -2938,7 +2938,7 @@
           <a:p>
             <a:fld id="{01A28B2F-B325-45E9-9465-5B309D137143}" type="datetimeFigureOut">
               <a:rPr lang="en-AU" smtClean="0"/>
-              <a:t>31/03/2026</a:t>
+              <a:t>19/04/2026</a:t>
             </a:fld>
             <a:endParaRPr lang="en-AU"/>
           </a:p>
@@ -3730,7 +3730,7 @@
           <a:p>
             <a:r>
               <a:rPr lang="en-AU" dirty="0"/>
-              <a:t>Explain how standardisation is by explaining what colour and stretch are and how the Tripp equation corrects for colour and stretch.</a:t>
+              <a:t>Explain what standardisation is by explaining what colour and stretch are and introduce the Tripp equation.</a:t>
             </a:r>
           </a:p>
           <a:p>
@@ -4028,15 +4028,7 @@
           <a:p>
             <a:r>
               <a:rPr lang="en-AU" dirty="0"/>
-              <a:t>Describe how correlations with local environment variables such as </a:t>
-            </a:r>
-            <a:r>
-              <a:rPr lang="en-AU" dirty="0" err="1"/>
-              <a:t>lsSFR</a:t>
-            </a:r>
-            <a:r>
-              <a:rPr lang="en-AU" dirty="0"/>
-              <a:t> and EW [OII] are improved standardisation tools than the mass step. </a:t>
+              <a:t>Describe how correlations with host galaxy properties (SFR, colour and DLR) are improved standardisation tools than the mass step. </a:t>
             </a:r>
           </a:p>
         </p:txBody>
@@ -4436,15 +4428,7 @@
           <a:p>
             <a:r>
               <a:rPr lang="en-AU" dirty="0"/>
-              <a:t>To detect and classify the early excess flux SNe Ia and investigate incidence rate as a function of host galaxy properties such as stellar mass, </a:t>
-            </a:r>
-            <a:r>
-              <a:rPr lang="en-AU" dirty="0" err="1"/>
-              <a:t>sSFR</a:t>
-            </a:r>
-            <a:r>
-              <a:rPr lang="en-AU" dirty="0"/>
-              <a:t> and colour. </a:t>
+              <a:t>To detect and classify the early excess flux SNe Ia and investigate incidence rate as a function of host galaxy properties such as stellar mass, SFR, host colour and DLR. </a:t>
             </a:r>
           </a:p>
           <a:p>

</xml_diff>